<commit_message>
Videos de pitch y demo en inglés, deck con equipo y guion alineado a las diapositivas
- Pitch (1:58) y demo de la versión Solana (2:57) con voz en inglés y subtítulos del guion, con sus .srt.
- Deck en inglés: diapositiva TEAM y la de go-to-market sin la cita del INV, como dice el guion.
- El guion dice +$500B, igual que la diapositiva del problema.
- README y PITCH/video-demo.md apuntan a los videos nuevos.

Co-Authored-By: Claude Opus 5.5 <noreply@anthropic.com>
</commit_message>
<xml_diff>
--- a/PITCH/VeriFire Pitch Deck (EN).pptx
+++ b/PITCH/VeriFire Pitch Deck (EN).pptx
@@ -16,6 +16,7 @@
     <p:sldId id="261" r:id="rId10"/>
     <p:sldId id="262" r:id="rId11"/>
     <p:sldId id="263" r:id="rId12"/>
+    <p:sldId id="267" r:id="rId22"/>
     <p:sldId id="264" r:id="rId13"/>
     <p:sldId id="265" r:id="rId14"/>
     <p:sldId id="266" r:id="rId15"/>
@@ -6983,6 +6984,1064 @@
           <a:noFill/>
           <a:ln>
             <a:noFill/>
+          </a:ln>
+        </p:spPr>
+      </p:pic>
+    </p:spTree>
+  </p:cSld>
+  <p:clrMapOvr>
+    <a:masterClrMapping/>
+  </p:clrMapOvr>
+</p:sld>
+</file>
+
+<file path=ppt/slides/slide12.xml><?xml version="1.0" encoding="utf-8"?>
+<p:sld xmlns:a="http://schemas.openxmlformats.org/drawingml/2006/main" xmlns:r="http://schemas.openxmlformats.org/officeDocument/2006/relationships" xmlns:mc="http://schemas.openxmlformats.org/markup-compatibility/2006" xmlns:mv="urn:schemas-microsoft-com:mac:vml" xmlns:p="http://schemas.openxmlformats.org/presentationml/2006/main" xmlns:c="http://schemas.openxmlformats.org/drawingml/2006/chart" xmlns:dgm="http://schemas.openxmlformats.org/drawingml/2006/diagram" xmlns:o="urn:schemas-microsoft-com:office:office" xmlns:v="urn:schemas-microsoft-com:vml" xmlns:pvml="urn:schemas-microsoft-com:office:powerpoint" xmlns:com="http://schemas.openxmlformats.org/drawingml/2006/compatibility" xmlns:p14="http://schemas.microsoft.com/office/powerpoint/2010/main" xmlns:p15="http://schemas.microsoft.com/office/powerpoint/2012/main" xmlns:ahyp="http://schemas.microsoft.com/office/drawing/2018/hyperlinkcolor">
+  <p:cSld>
+    <p:bg>
+      <p:bgPr>
+        <a:solidFill>
+          <a:srgbClr val="000000"/>
+        </a:solidFill>
+      </p:bgPr>
+    </p:bg>
+    <p:spTree>
+      <p:nvGrpSpPr>
+        <p:cNvPr id="132" name="Shape 132"/>
+        <p:cNvGrpSpPr/>
+        <p:nvPr/>
+      </p:nvGrpSpPr>
+      <p:grpSpPr>
+        <a:xfrm>
+          <a:off x="0" y="0"/>
+          <a:ext cx="0" cy="0"/>
+          <a:chOff x="0" y="0"/>
+          <a:chExt cx="0" cy="0"/>
+        </a:xfrm>
+      </p:grpSpPr>
+      <p:grpSp>
+        <p:nvGrpSpPr>
+          <p:cNvPr id="133" name="Google Shape;133;p21"/>
+          <p:cNvGrpSpPr/>
+          <p:nvPr/>
+        </p:nvGrpSpPr>
+        <p:grpSpPr>
+          <a:xfrm>
+            <a:off x="571500" y="342900"/>
+            <a:ext cx="8001000" cy="705000"/>
+            <a:chOff x="0" y="0"/>
+            <a:chExt cx="8001000" cy="705000"/>
+          </a:xfrm>
+        </p:grpSpPr>
+        <p:sp>
+          <p:nvSpPr>
+            <p:cNvPr id="134" name="Google Shape;134;p21"/>
+            <p:cNvSpPr/>
+            <p:nvPr/>
+          </p:nvSpPr>
+          <p:spPr>
+            <a:xfrm>
+              <a:off x="0" y="0"/>
+              <a:ext cx="1524000" cy="247800"/>
+            </a:xfrm>
+            <a:prstGeom prst="roundRect">
+              <a:avLst>
+                <a:gd fmla="val 50000" name="adj"/>
+              </a:avLst>
+            </a:prstGeom>
+            <a:solidFill>
+              <a:srgbClr val="1F1115"/>
+            </a:solidFill>
+            <a:ln cap="flat" cmpd="sng" w="9525">
+              <a:solidFill>
+                <a:srgbClr val="4A151B"/>
+              </a:solidFill>
+              <a:prstDash val="solid"/>
+              <a:round/>
+              <a:headEnd len="sm" w="sm" type="none"/>
+              <a:tailEnd len="sm" w="sm" type="none"/>
+            </a:ln>
+          </p:spPr>
+          <p:txBody>
+            <a:bodyPr anchorCtr="0" anchor="ctr" bIns="0" lIns="0" spcFirstLastPara="1" rIns="0" wrap="square" tIns="0">
+              <a:noAutofit/>
+            </a:bodyPr>
+            <a:lstStyle/>
+            <a:p>
+              <a:pPr indent="0" lvl="0" marL="0" rtl="0" algn="l">
+                <a:spcBef>
+                  <a:spcPts val="0"/>
+                </a:spcBef>
+                <a:spcAft>
+                  <a:spcPts val="0"/>
+                </a:spcAft>
+                <a:buNone/>
+              </a:pPr>
+              <a:r>
+                <a:t/>
+              </a:r>
+              <a:endParaRPr/>
+            </a:p>
+          </p:txBody>
+        </p:sp>
+        <p:sp>
+          <p:nvSpPr>
+            <p:cNvPr id="135" name="Google Shape;135;p21"/>
+            <p:cNvSpPr txBox="1"/>
+            <p:nvPr/>
+          </p:nvSpPr>
+          <p:spPr>
+            <a:xfrm>
+              <a:off x="0" y="0"/>
+              <a:ext cx="1524000" cy="247800"/>
+            </a:xfrm>
+            <a:prstGeom prst="rect">
+              <a:avLst/>
+            </a:prstGeom>
+            <a:noFill/>
+            <a:ln>
+              <a:noFill/>
+            </a:ln>
+          </p:spPr>
+          <p:txBody>
+            <a:bodyPr anchorCtr="0" anchor="ctr" bIns="0" lIns="0" spcFirstLastPara="1" rIns="0" wrap="square" tIns="0">
+              <a:noAutofit/>
+            </a:bodyPr>
+            <a:lstStyle/>
+            <a:p>
+              <a:pPr indent="0" lvl="0" marL="0" rtl="0" algn="ctr">
+                <a:spcBef>
+                  <a:spcPts val="0"/>
+                </a:spcBef>
+                <a:spcAft>
+                  <a:spcPts val="0"/>
+                </a:spcAft>
+                <a:buNone/>
+              </a:pPr>
+              <a:r>
+                <a:rPr b="0" lang="es-419" sz="786">
+                  <a:solidFill>
+                    <a:srgbClr val="FF3B4B"/>
+                  </a:solidFill>
+                  <a:latin typeface="Nunito ExtraBold"/>
+                  <a:ea typeface="Nunito ExtraBold"/>
+                  <a:cs typeface="Nunito ExtraBold"/>
+                  <a:sym typeface="Nunito ExtraBold"/>
+                </a:rPr>
+                <a:t>TEAM</a:t>
+              </a:r>
+              <a:endParaRPr sz="1085"/>
+            </a:p>
+          </p:txBody>
+        </p:sp>
+        <p:sp>
+          <p:nvSpPr>
+            <p:cNvPr id="136" name="Google Shape;136;p21"/>
+            <p:cNvSpPr txBox="1"/>
+            <p:nvPr/>
+          </p:nvSpPr>
+          <p:spPr>
+            <a:xfrm>
+              <a:off x="0" y="304800"/>
+              <a:ext cx="8001000" cy="400200"/>
+            </a:xfrm>
+            <a:prstGeom prst="rect">
+              <a:avLst/>
+            </a:prstGeom>
+            <a:noFill/>
+            <a:ln>
+              <a:noFill/>
+            </a:ln>
+          </p:spPr>
+          <p:txBody>
+            <a:bodyPr anchorCtr="0" anchor="t" bIns="0" lIns="0" spcFirstLastPara="1" rIns="0" wrap="square" tIns="0">
+              <a:noAutofit/>
+            </a:bodyPr>
+            <a:lstStyle/>
+            <a:p>
+              <a:pPr indent="0" lvl="0" marL="0" rtl="0" algn="ctr">
+                <a:spcBef>
+                  <a:spcPts val="0"/>
+                </a:spcBef>
+                <a:spcAft>
+                  <a:spcPts val="0"/>
+                </a:spcAft>
+                <a:buNone/>
+              </a:pPr>
+              <a:r>
+                <a:rPr b="1" lang="es-419" sz="2200">
+                  <a:solidFill>
+                    <a:srgbClr val="FFFFFF"/>
+                  </a:solidFill>
+                  <a:latin typeface="Nunito"/>
+                  <a:ea typeface="Nunito"/>
+                  <a:cs typeface="Nunito"/>
+                  <a:sym typeface="Nunito"/>
+                </a:rPr>
+                <a:t>Built in Salta, a few hours from Cafayate</a:t>
+              </a:r>
+              <a:endParaRPr sz="1085"/>
+            </a:p>
+          </p:txBody>
+        </p:sp>
+      </p:grpSp>
+      <p:grpSp>
+        <p:nvGrpSpPr>
+          <p:cNvPr id="137" name="Google Shape;137;p21"/>
+          <p:cNvGrpSpPr/>
+          <p:nvPr/>
+        </p:nvGrpSpPr>
+        <p:grpSpPr>
+          <a:xfrm>
+            <a:off x="571500" y="1428750"/>
+            <a:ext cx="1619100" cy="2571900"/>
+            <a:chOff x="0" y="0"/>
+            <a:chExt cx="1619100" cy="2571900"/>
+          </a:xfrm>
+        </p:grpSpPr>
+        <p:sp>
+          <p:nvSpPr>
+            <p:cNvPr id="138" name="Google Shape;138;p21"/>
+            <p:cNvSpPr/>
+            <p:nvPr/>
+          </p:nvSpPr>
+          <p:spPr>
+            <a:xfrm>
+              <a:off x="0" y="0"/>
+              <a:ext cx="1619100" cy="2571900"/>
+            </a:xfrm>
+            <a:prstGeom prst="roundRect">
+              <a:avLst>
+                <a:gd fmla="val 9411" name="adj"/>
+              </a:avLst>
+            </a:prstGeom>
+            <a:solidFill>
+              <a:srgbClr val="0D0D11"/>
+            </a:solidFill>
+            <a:ln cap="flat" cmpd="sng" w="14300">
+              <a:solidFill>
+                <a:srgbClr val="261418"/>
+              </a:solidFill>
+              <a:prstDash val="solid"/>
+              <a:round/>
+              <a:headEnd len="sm" w="sm" type="none"/>
+              <a:tailEnd len="sm" w="sm" type="none"/>
+            </a:ln>
+          </p:spPr>
+          <p:txBody>
+            <a:bodyPr anchorCtr="0" anchor="ctr" bIns="0" lIns="0" spcFirstLastPara="1" rIns="0" wrap="square" tIns="0">
+              <a:noAutofit/>
+            </a:bodyPr>
+            <a:lstStyle/>
+            <a:p>
+              <a:pPr indent="0" lvl="0" marL="0" rtl="0" algn="l">
+                <a:spcBef>
+                  <a:spcPts val="0"/>
+                </a:spcBef>
+                <a:spcAft>
+                  <a:spcPts val="0"/>
+                </a:spcAft>
+                <a:buNone/>
+              </a:pPr>
+              <a:r>
+                <a:t/>
+              </a:r>
+              <a:endParaRPr/>
+            </a:p>
+          </p:txBody>
+        </p:sp>
+        <p:sp>
+          <p:nvSpPr>
+            <p:cNvPr id="139" name="Google Shape;139;p21"/>
+            <p:cNvSpPr/>
+            <p:nvPr/>
+          </p:nvSpPr>
+          <p:spPr>
+            <a:xfrm>
+              <a:off x="190500" y="0"/>
+              <a:ext cx="381000" cy="28500"/>
+            </a:xfrm>
+            <a:prstGeom prst="roundRect">
+              <a:avLst>
+                <a:gd fmla="val 50000" name="adj"/>
+              </a:avLst>
+            </a:prstGeom>
+            <a:solidFill>
+              <a:srgbClr val="FF3B4B"/>
+            </a:solidFill>
+            <a:ln>
+              <a:noFill/>
+            </a:ln>
+          </p:spPr>
+          <p:txBody>
+            <a:bodyPr anchorCtr="0" anchor="ctr" bIns="0" lIns="0" spcFirstLastPara="1" rIns="0" wrap="square" tIns="0">
+              <a:noAutofit/>
+            </a:bodyPr>
+            <a:lstStyle/>
+            <a:p>
+              <a:pPr indent="0" lvl="0" marL="0" rtl="0" algn="l">
+                <a:spcBef>
+                  <a:spcPts val="0"/>
+                </a:spcBef>
+                <a:spcAft>
+                  <a:spcPts val="0"/>
+                </a:spcAft>
+                <a:buNone/>
+              </a:pPr>
+              <a:r>
+                <a:t/>
+              </a:r>
+              <a:endParaRPr/>
+            </a:p>
+          </p:txBody>
+        </p:sp>
+        <p:sp>
+          <p:nvSpPr>
+            <p:cNvPr id="140" name="Google Shape;140;p21"/>
+            <p:cNvSpPr txBox="1"/>
+            <p:nvPr/>
+          </p:nvSpPr>
+          <p:spPr>
+            <a:xfrm>
+              <a:off x="190500" y="190500"/>
+              <a:ext cx="1238400" cy="2190900"/>
+            </a:xfrm>
+            <a:prstGeom prst="rect">
+              <a:avLst/>
+            </a:prstGeom>
+            <a:noFill/>
+            <a:ln>
+              <a:noFill/>
+            </a:ln>
+          </p:spPr>
+          <p:txBody>
+            <a:bodyPr anchorCtr="0" anchor="t" bIns="0" lIns="0" spcFirstLastPara="1" rIns="0" wrap="square" tIns="0">
+              <a:noAutofit/>
+            </a:bodyPr>
+            <a:lstStyle/>
+            <a:p>
+              <a:pPr indent="0" lvl="0" marL="0" rtl="0" algn="l">
+                <a:spcBef>
+                  <a:spcPts val="0"/>
+                </a:spcBef>
+                <a:spcAft>
+                  <a:spcPts val="0"/>
+                </a:spcAft>
+                <a:buNone/>
+              </a:pPr>
+              <a:r>
+                <a:rPr b="0" lang="es-419" sz="620">
+                  <a:solidFill>
+                    <a:srgbClr val="FF3B4B"/>
+                  </a:solidFill>
+                  <a:latin typeface="Nunito ExtraBold"/>
+                  <a:ea typeface="Nunito ExtraBold"/>
+                  <a:cs typeface="Nunito ExtraBold"/>
+                  <a:sym typeface="Nunito ExtraBold"/>
+                </a:rPr>
+                <a:t>LEAD DEVELOPER</a:t>
+              </a:r>
+              <a:endParaRPr b="0" sz="620">
+                <a:solidFill>
+                  <a:srgbClr val="FF3B4B"/>
+                </a:solidFill>
+                <a:latin typeface="Nunito ExtraBold"/>
+                <a:ea typeface="Nunito ExtraBold"/>
+                <a:cs typeface="Nunito ExtraBold"/>
+                <a:sym typeface="Nunito ExtraBold"/>
+              </a:endParaRPr>
+            </a:p>
+            <a:p>
+              <a:pPr indent="0" lvl="0" marL="0" rtl="0" algn="l">
+                <a:spcBef>
+                  <a:spcPts val="600"/>
+                </a:spcBef>
+                <a:spcAft>
+                  <a:spcPts val="0"/>
+                </a:spcAft>
+                <a:buNone/>
+              </a:pPr>
+              <a:r>
+                <a:rPr b="0" lang="es-419" sz="2170">
+                  <a:solidFill>
+                    <a:srgbClr val="FF3B4B"/>
+                  </a:solidFill>
+                  <a:latin typeface="Nunito ExtraBold"/>
+                  <a:ea typeface="Nunito ExtraBold"/>
+                  <a:cs typeface="Nunito ExtraBold"/>
+                  <a:sym typeface="Nunito ExtraBold"/>
+                </a:rPr>
+                <a:t>Franco</a:t>
+              </a:r>
+              <a:endParaRPr b="0" sz="2170">
+                <a:solidFill>
+                  <a:srgbClr val="FF3B4B"/>
+                </a:solidFill>
+                <a:latin typeface="Nunito ExtraBold"/>
+                <a:ea typeface="Nunito ExtraBold"/>
+                <a:cs typeface="Nunito ExtraBold"/>
+                <a:sym typeface="Nunito ExtraBold"/>
+              </a:endParaRPr>
+            </a:p>
+            <a:p>
+              <a:pPr indent="0" lvl="0" marL="0" rtl="0" algn="l">
+                <a:spcBef>
+                  <a:spcPts val="300"/>
+                </a:spcBef>
+                <a:spcAft>
+                  <a:spcPts val="0"/>
+                </a:spcAft>
+                <a:buNone/>
+              </a:pPr>
+              <a:r>
+                <a:rPr b="1" lang="es-419" sz="1085">
+                  <a:solidFill>
+                    <a:srgbClr val="FFFFFF"/>
+                  </a:solidFill>
+                  <a:latin typeface="Nunito"/>
+                  <a:ea typeface="Nunito"/>
+                  <a:cs typeface="Nunito"/>
+                  <a:sym typeface="Nunito"/>
+                </a:rPr>
+                <a:t>Mamani</a:t>
+              </a:r>
+              <a:endParaRPr b="1" sz="1085">
+                <a:solidFill>
+                  <a:srgbClr val="FFFFFF"/>
+                </a:solidFill>
+                <a:latin typeface="Nunito"/>
+                <a:ea typeface="Nunito"/>
+                <a:cs typeface="Nunito"/>
+                <a:sym typeface="Nunito"/>
+              </a:endParaRPr>
+            </a:p>
+            <a:p>
+              <a:pPr indent="0" lvl="0" marL="0" rtl="0" algn="l">
+                <a:spcBef>
+                  <a:spcPts val="600"/>
+                </a:spcBef>
+                <a:spcAft>
+                  <a:spcPts val="0"/>
+                </a:spcAft>
+                <a:buNone/>
+              </a:pPr>
+              <a:r>
+                <a:rPr b="0" lang="es-419" sz="775">
+                  <a:solidFill>
+                    <a:srgbClr val="7C7C85"/>
+                  </a:solidFill>
+                  <a:latin typeface="Nunito"/>
+                  <a:ea typeface="Nunito"/>
+                  <a:cs typeface="Nunito"/>
+                  <a:sym typeface="Nunito"/>
+                </a:rPr>
+                <a:t>Solana program, backend and payments. Argentina Builders.</a:t>
+              </a:r>
+              <a:endParaRPr b="0" sz="775">
+                <a:solidFill>
+                  <a:srgbClr val="7C7C85"/>
+                </a:solidFill>
+                <a:latin typeface="Nunito"/>
+                <a:ea typeface="Nunito"/>
+                <a:cs typeface="Nunito"/>
+                <a:sym typeface="Nunito"/>
+              </a:endParaRPr>
+            </a:p>
+          </p:txBody>
+        </p:sp>
+      </p:grpSp>
+      <p:grpSp>
+        <p:nvGrpSpPr>
+          <p:cNvPr id="141" name="Google Shape;141;p21"/>
+          <p:cNvGrpSpPr/>
+          <p:nvPr/>
+        </p:nvGrpSpPr>
+        <p:grpSpPr>
+          <a:xfrm>
+            <a:off x="2381250" y="1428750"/>
+            <a:ext cx="1619100" cy="2571900"/>
+            <a:chOff x="0" y="0"/>
+            <a:chExt cx="1619100" cy="2571900"/>
+          </a:xfrm>
+        </p:grpSpPr>
+        <p:sp>
+          <p:nvSpPr>
+            <p:cNvPr id="142" name="Google Shape;142;p21"/>
+            <p:cNvSpPr/>
+            <p:nvPr/>
+          </p:nvSpPr>
+          <p:spPr>
+            <a:xfrm>
+              <a:off x="0" y="0"/>
+              <a:ext cx="1619100" cy="2571900"/>
+            </a:xfrm>
+            <a:prstGeom prst="roundRect">
+              <a:avLst>
+                <a:gd fmla="val 9411" name="adj"/>
+              </a:avLst>
+            </a:prstGeom>
+            <a:solidFill>
+              <a:srgbClr val="0D0D11"/>
+            </a:solidFill>
+            <a:ln cap="flat" cmpd="sng" w="14300">
+              <a:solidFill>
+                <a:srgbClr val="261418"/>
+              </a:solidFill>
+              <a:prstDash val="solid"/>
+              <a:round/>
+              <a:headEnd len="sm" w="sm" type="none"/>
+              <a:tailEnd len="sm" w="sm" type="none"/>
+            </a:ln>
+          </p:spPr>
+          <p:txBody>
+            <a:bodyPr anchorCtr="0" anchor="ctr" bIns="0" lIns="0" spcFirstLastPara="1" rIns="0" wrap="square" tIns="0">
+              <a:noAutofit/>
+            </a:bodyPr>
+            <a:lstStyle/>
+            <a:p>
+              <a:pPr indent="0" lvl="0" marL="0" rtl="0" algn="l">
+                <a:spcBef>
+                  <a:spcPts val="0"/>
+                </a:spcBef>
+                <a:spcAft>
+                  <a:spcPts val="0"/>
+                </a:spcAft>
+                <a:buNone/>
+              </a:pPr>
+              <a:r>
+                <a:t/>
+              </a:r>
+              <a:endParaRPr/>
+            </a:p>
+          </p:txBody>
+        </p:sp>
+        <p:sp>
+          <p:nvSpPr>
+            <p:cNvPr id="143" name="Google Shape;143;p21"/>
+            <p:cNvSpPr/>
+            <p:nvPr/>
+          </p:nvSpPr>
+          <p:spPr>
+            <a:xfrm>
+              <a:off x="190500" y="0"/>
+              <a:ext cx="381000" cy="28500"/>
+            </a:xfrm>
+            <a:prstGeom prst="roundRect">
+              <a:avLst>
+                <a:gd fmla="val 50000" name="adj"/>
+              </a:avLst>
+            </a:prstGeom>
+            <a:solidFill>
+              <a:srgbClr val="FF3B4B"/>
+            </a:solidFill>
+            <a:ln>
+              <a:noFill/>
+            </a:ln>
+          </p:spPr>
+          <p:txBody>
+            <a:bodyPr anchorCtr="0" anchor="ctr" bIns="0" lIns="0" spcFirstLastPara="1" rIns="0" wrap="square" tIns="0">
+              <a:noAutofit/>
+            </a:bodyPr>
+            <a:lstStyle/>
+            <a:p>
+              <a:pPr indent="0" lvl="0" marL="0" rtl="0" algn="l">
+                <a:spcBef>
+                  <a:spcPts val="0"/>
+                </a:spcBef>
+                <a:spcAft>
+                  <a:spcPts val="0"/>
+                </a:spcAft>
+                <a:buNone/>
+              </a:pPr>
+              <a:r>
+                <a:t/>
+              </a:r>
+              <a:endParaRPr/>
+            </a:p>
+          </p:txBody>
+        </p:sp>
+        <p:sp>
+          <p:nvSpPr>
+            <p:cNvPr id="144" name="Google Shape;144;p21"/>
+            <p:cNvSpPr txBox="1"/>
+            <p:nvPr/>
+          </p:nvSpPr>
+          <p:spPr>
+            <a:xfrm>
+              <a:off x="190500" y="190500"/>
+              <a:ext cx="1238400" cy="2190900"/>
+            </a:xfrm>
+            <a:prstGeom prst="rect">
+              <a:avLst/>
+            </a:prstGeom>
+            <a:noFill/>
+            <a:ln>
+              <a:noFill/>
+            </a:ln>
+          </p:spPr>
+          <p:txBody>
+            <a:bodyPr anchorCtr="0" anchor="t" bIns="0" lIns="0" spcFirstLastPara="1" rIns="0" wrap="square" tIns="0">
+              <a:noAutofit/>
+            </a:bodyPr>
+            <a:lstStyle/>
+            <a:p>
+              <a:pPr indent="0" lvl="0" marL="0" rtl="0" algn="l">
+                <a:spcBef>
+                  <a:spcPts val="0"/>
+                </a:spcBef>
+                <a:spcAft>
+                  <a:spcPts val="0"/>
+                </a:spcAft>
+                <a:buNone/>
+              </a:pPr>
+              <a:r>
+                <a:rPr b="0" lang="es-419" sz="620">
+                  <a:solidFill>
+                    <a:srgbClr val="FF3B4B"/>
+                  </a:solidFill>
+                  <a:latin typeface="Nunito ExtraBold"/>
+                  <a:ea typeface="Nunito ExtraBold"/>
+                  <a:cs typeface="Nunito ExtraBold"/>
+                  <a:sym typeface="Nunito ExtraBold"/>
+                </a:rPr>
+                <a:t>DEVELOPER</a:t>
+              </a:r>
+              <a:endParaRPr b="0" sz="620">
+                <a:solidFill>
+                  <a:srgbClr val="FF3B4B"/>
+                </a:solidFill>
+                <a:latin typeface="Nunito ExtraBold"/>
+                <a:ea typeface="Nunito ExtraBold"/>
+                <a:cs typeface="Nunito ExtraBold"/>
+                <a:sym typeface="Nunito ExtraBold"/>
+              </a:endParaRPr>
+            </a:p>
+            <a:p>
+              <a:pPr indent="0" lvl="0" marL="0" rtl="0" algn="l">
+                <a:spcBef>
+                  <a:spcPts val="600"/>
+                </a:spcBef>
+                <a:spcAft>
+                  <a:spcPts val="0"/>
+                </a:spcAft>
+                <a:buNone/>
+              </a:pPr>
+              <a:r>
+                <a:rPr b="0" lang="es-419" sz="2170">
+                  <a:solidFill>
+                    <a:srgbClr val="FF3B4B"/>
+                  </a:solidFill>
+                  <a:latin typeface="Nunito ExtraBold"/>
+                  <a:ea typeface="Nunito ExtraBold"/>
+                  <a:cs typeface="Nunito ExtraBold"/>
+                  <a:sym typeface="Nunito ExtraBold"/>
+                </a:rPr>
+                <a:t>Jorge</a:t>
+              </a:r>
+              <a:endParaRPr b="0" sz="2170">
+                <a:solidFill>
+                  <a:srgbClr val="FF3B4B"/>
+                </a:solidFill>
+                <a:latin typeface="Nunito ExtraBold"/>
+                <a:ea typeface="Nunito ExtraBold"/>
+                <a:cs typeface="Nunito ExtraBold"/>
+                <a:sym typeface="Nunito ExtraBold"/>
+              </a:endParaRPr>
+            </a:p>
+            <a:p>
+              <a:pPr indent="0" lvl="0" marL="0" rtl="0" algn="l">
+                <a:spcBef>
+                  <a:spcPts val="300"/>
+                </a:spcBef>
+                <a:spcAft>
+                  <a:spcPts val="0"/>
+                </a:spcAft>
+                <a:buNone/>
+              </a:pPr>
+              <a:r>
+                <a:rPr b="1" lang="es-419" sz="1085">
+                  <a:solidFill>
+                    <a:srgbClr val="FFFFFF"/>
+                  </a:solidFill>
+                  <a:latin typeface="Nunito"/>
+                  <a:ea typeface="Nunito"/>
+                  <a:cs typeface="Nunito"/>
+                  <a:sym typeface="Nunito"/>
+                </a:rPr>
+                <a:t>Conte</a:t>
+              </a:r>
+              <a:endParaRPr b="1" sz="1085">
+                <a:solidFill>
+                  <a:srgbClr val="FFFFFF"/>
+                </a:solidFill>
+                <a:latin typeface="Nunito"/>
+                <a:ea typeface="Nunito"/>
+                <a:cs typeface="Nunito"/>
+                <a:sym typeface="Nunito"/>
+              </a:endParaRPr>
+            </a:p>
+            <a:p>
+              <a:pPr indent="0" lvl="0" marL="0" rtl="0" algn="l">
+                <a:spcBef>
+                  <a:spcPts val="600"/>
+                </a:spcBef>
+                <a:spcAft>
+                  <a:spcPts val="0"/>
+                </a:spcAft>
+                <a:buNone/>
+              </a:pPr>
+              <a:r>
+                <a:rPr b="0" lang="es-419" sz="775">
+                  <a:solidFill>
+                    <a:srgbClr val="7C7C85"/>
+                  </a:solidFill>
+                  <a:latin typeface="Nunito"/>
+                  <a:ea typeface="Nunito"/>
+                  <a:cs typeface="Nunito"/>
+                  <a:sym typeface="Nunito"/>
+                </a:rPr>
+                <a:t>Company panel. Argentina Builders.</a:t>
+              </a:r>
+              <a:endParaRPr b="0" sz="775">
+                <a:solidFill>
+                  <a:srgbClr val="7C7C85"/>
+                </a:solidFill>
+                <a:latin typeface="Nunito"/>
+                <a:ea typeface="Nunito"/>
+                <a:cs typeface="Nunito"/>
+                <a:sym typeface="Nunito"/>
+              </a:endParaRPr>
+            </a:p>
+          </p:txBody>
+        </p:sp>
+      </p:grpSp>
+      <p:grpSp>
+        <p:nvGrpSpPr>
+          <p:cNvPr id="145" name="Google Shape;145;p21"/>
+          <p:cNvGrpSpPr/>
+          <p:nvPr/>
+        </p:nvGrpSpPr>
+        <p:grpSpPr>
+          <a:xfrm>
+            <a:off x="4191000" y="1428750"/>
+            <a:ext cx="1619100" cy="2571900"/>
+            <a:chOff x="0" y="0"/>
+            <a:chExt cx="1619100" cy="2571900"/>
+          </a:xfrm>
+        </p:grpSpPr>
+        <p:sp>
+          <p:nvSpPr>
+            <p:cNvPr id="146" name="Google Shape;146;p21"/>
+            <p:cNvSpPr/>
+            <p:nvPr/>
+          </p:nvSpPr>
+          <p:spPr>
+            <a:xfrm>
+              <a:off x="0" y="0"/>
+              <a:ext cx="1619100" cy="2571900"/>
+            </a:xfrm>
+            <a:prstGeom prst="roundRect">
+              <a:avLst>
+                <a:gd fmla="val 9411" name="adj"/>
+              </a:avLst>
+            </a:prstGeom>
+            <a:solidFill>
+              <a:srgbClr val="0D0D11"/>
+            </a:solidFill>
+            <a:ln cap="flat" cmpd="sng" w="14300">
+              <a:solidFill>
+                <a:srgbClr val="261418"/>
+              </a:solidFill>
+              <a:prstDash val="solid"/>
+              <a:round/>
+              <a:headEnd len="sm" w="sm" type="none"/>
+              <a:tailEnd len="sm" w="sm" type="none"/>
+            </a:ln>
+          </p:spPr>
+          <p:txBody>
+            <a:bodyPr anchorCtr="0" anchor="ctr" bIns="0" lIns="0" spcFirstLastPara="1" rIns="0" wrap="square" tIns="0">
+              <a:noAutofit/>
+            </a:bodyPr>
+            <a:lstStyle/>
+            <a:p>
+              <a:pPr indent="0" lvl="0" marL="0" rtl="0" algn="l">
+                <a:spcBef>
+                  <a:spcPts val="0"/>
+                </a:spcBef>
+                <a:spcAft>
+                  <a:spcPts val="0"/>
+                </a:spcAft>
+                <a:buNone/>
+              </a:pPr>
+              <a:r>
+                <a:t/>
+              </a:r>
+              <a:endParaRPr/>
+            </a:p>
+          </p:txBody>
+        </p:sp>
+        <p:sp>
+          <p:nvSpPr>
+            <p:cNvPr id="147" name="Google Shape;147;p21"/>
+            <p:cNvSpPr/>
+            <p:nvPr/>
+          </p:nvSpPr>
+          <p:spPr>
+            <a:xfrm>
+              <a:off x="190500" y="0"/>
+              <a:ext cx="381000" cy="28500"/>
+            </a:xfrm>
+            <a:prstGeom prst="roundRect">
+              <a:avLst>
+                <a:gd fmla="val 50000" name="adj"/>
+              </a:avLst>
+            </a:prstGeom>
+            <a:solidFill>
+              <a:srgbClr val="FF3B4B"/>
+            </a:solidFill>
+            <a:ln>
+              <a:noFill/>
+            </a:ln>
+          </p:spPr>
+          <p:txBody>
+            <a:bodyPr anchorCtr="0" anchor="ctr" bIns="0" lIns="0" spcFirstLastPara="1" rIns="0" wrap="square" tIns="0">
+              <a:noAutofit/>
+            </a:bodyPr>
+            <a:lstStyle/>
+            <a:p>
+              <a:pPr indent="0" lvl="0" marL="0" rtl="0" algn="l">
+                <a:spcBef>
+                  <a:spcPts val="0"/>
+                </a:spcBef>
+                <a:spcAft>
+                  <a:spcPts val="0"/>
+                </a:spcAft>
+                <a:buNone/>
+              </a:pPr>
+              <a:r>
+                <a:t/>
+              </a:r>
+              <a:endParaRPr/>
+            </a:p>
+          </p:txBody>
+        </p:sp>
+        <p:sp>
+          <p:nvSpPr>
+            <p:cNvPr id="148" name="Google Shape;148;p21"/>
+            <p:cNvSpPr txBox="1"/>
+            <p:nvPr/>
+          </p:nvSpPr>
+          <p:spPr>
+            <a:xfrm>
+              <a:off x="190500" y="190500"/>
+              <a:ext cx="1238400" cy="2190900"/>
+            </a:xfrm>
+            <a:prstGeom prst="rect">
+              <a:avLst/>
+            </a:prstGeom>
+            <a:noFill/>
+            <a:ln>
+              <a:noFill/>
+            </a:ln>
+          </p:spPr>
+          <p:txBody>
+            <a:bodyPr anchorCtr="0" anchor="t" bIns="0" lIns="0" spcFirstLastPara="1" rIns="0" wrap="square" tIns="0">
+              <a:noAutofit/>
+            </a:bodyPr>
+            <a:lstStyle/>
+            <a:p>
+              <a:pPr indent="0" lvl="0" marL="0" rtl="0" algn="l">
+                <a:spcBef>
+                  <a:spcPts val="0"/>
+                </a:spcBef>
+                <a:spcAft>
+                  <a:spcPts val="0"/>
+                </a:spcAft>
+                <a:buNone/>
+              </a:pPr>
+              <a:r>
+                <a:rPr b="0" lang="es-419" sz="620">
+                  <a:solidFill>
+                    <a:srgbClr val="FF3B4B"/>
+                  </a:solidFill>
+                  <a:latin typeface="Nunito ExtraBold"/>
+                  <a:ea typeface="Nunito ExtraBold"/>
+                  <a:cs typeface="Nunito ExtraBold"/>
+                  <a:sym typeface="Nunito ExtraBold"/>
+                </a:rPr>
+                <a:t>DEVELOPER</a:t>
+              </a:r>
+              <a:endParaRPr b="0" sz="620">
+                <a:solidFill>
+                  <a:srgbClr val="FF3B4B"/>
+                </a:solidFill>
+                <a:latin typeface="Nunito ExtraBold"/>
+                <a:ea typeface="Nunito ExtraBold"/>
+                <a:cs typeface="Nunito ExtraBold"/>
+                <a:sym typeface="Nunito ExtraBold"/>
+              </a:endParaRPr>
+            </a:p>
+            <a:p>
+              <a:pPr indent="0" lvl="0" marL="0" rtl="0" algn="l">
+                <a:spcBef>
+                  <a:spcPts val="600"/>
+                </a:spcBef>
+                <a:spcAft>
+                  <a:spcPts val="0"/>
+                </a:spcAft>
+                <a:buNone/>
+              </a:pPr>
+              <a:r>
+                <a:rPr b="0" lang="es-419" sz="2170">
+                  <a:solidFill>
+                    <a:srgbClr val="FF3B4B"/>
+                  </a:solidFill>
+                  <a:latin typeface="Nunito ExtraBold"/>
+                  <a:ea typeface="Nunito ExtraBold"/>
+                  <a:cs typeface="Nunito ExtraBold"/>
+                  <a:sym typeface="Nunito ExtraBold"/>
+                </a:rPr>
+                <a:t>Emanuel</a:t>
+              </a:r>
+              <a:endParaRPr b="0" sz="2170">
+                <a:solidFill>
+                  <a:srgbClr val="FF3B4B"/>
+                </a:solidFill>
+                <a:latin typeface="Nunito ExtraBold"/>
+                <a:ea typeface="Nunito ExtraBold"/>
+                <a:cs typeface="Nunito ExtraBold"/>
+                <a:sym typeface="Nunito ExtraBold"/>
+              </a:endParaRPr>
+            </a:p>
+            <a:p>
+              <a:pPr indent="0" lvl="0" marL="0" rtl="0" algn="l">
+                <a:spcBef>
+                  <a:spcPts val="300"/>
+                </a:spcBef>
+                <a:spcAft>
+                  <a:spcPts val="0"/>
+                </a:spcAft>
+                <a:buNone/>
+              </a:pPr>
+              <a:r>
+                <a:rPr b="1" lang="es-419" sz="1085">
+                  <a:solidFill>
+                    <a:srgbClr val="FFFFFF"/>
+                  </a:solidFill>
+                  <a:latin typeface="Nunito"/>
+                  <a:ea typeface="Nunito"/>
+                  <a:cs typeface="Nunito"/>
+                  <a:sym typeface="Nunito"/>
+                </a:rPr>
+                <a:t>Guzman</a:t>
+              </a:r>
+              <a:endParaRPr b="1" sz="1085">
+                <a:solidFill>
+                  <a:srgbClr val="FFFFFF"/>
+                </a:solidFill>
+                <a:latin typeface="Nunito"/>
+                <a:ea typeface="Nunito"/>
+                <a:cs typeface="Nunito"/>
+                <a:sym typeface="Nunito"/>
+              </a:endParaRPr>
+            </a:p>
+            <a:p>
+              <a:pPr indent="0" lvl="0" marL="0" rtl="0" algn="l">
+                <a:spcBef>
+                  <a:spcPts val="600"/>
+                </a:spcBef>
+                <a:spcAft>
+                  <a:spcPts val="0"/>
+                </a:spcAft>
+                <a:buNone/>
+              </a:pPr>
+              <a:r>
+                <a:rPr b="0" lang="es-419" sz="775">
+                  <a:solidFill>
+                    <a:srgbClr val="7C7C85"/>
+                  </a:solidFill>
+                  <a:latin typeface="Nunito"/>
+                  <a:ea typeface="Nunito"/>
+                  <a:cs typeface="Nunito"/>
+                  <a:sym typeface="Nunito"/>
+                </a:rPr>
+                <a:t>Landing and web app. 5 years building for clients.</a:t>
+              </a:r>
+              <a:endParaRPr b="0" sz="775">
+                <a:solidFill>
+                  <a:srgbClr val="7C7C85"/>
+                </a:solidFill>
+                <a:latin typeface="Nunito"/>
+                <a:ea typeface="Nunito"/>
+                <a:cs typeface="Nunito"/>
+                <a:sym typeface="Nunito"/>
+              </a:endParaRPr>
+            </a:p>
+          </p:txBody>
+        </p:sp>
+      </p:grpSp>
+      <p:pic>
+        <p:nvPicPr>
+          <p:cNvPr id="149" name="Google Shape;149;p21"/>
+          <p:cNvPicPr preferRelativeResize="0"/>
+          <p:nvPr/>
+        </p:nvPicPr>
+        <p:blipFill rotWithShape="1">
+          <a:blip r:embed="rId3">
+            <a:alphaModFix/>
+          </a:blip>
+          <a:srcRect b="0" l="179" r="189" t="0"/>
+          <a:stretch/>
+        </p:blipFill>
+        <p:spPr>
+          <a:xfrm>
+            <a:off x="571500" y="4305300"/>
+            <a:ext cx="476400" cy="619200"/>
+          </a:xfrm>
+          <a:prstGeom prst="rect">
+            <a:avLst/>
+          </a:prstGeom>
+          <a:noFill/>
+          <a:ln>
+            <a:noFill/>
+          </a:ln>
+        </p:spPr>
+      </p:pic>
+      <p:pic>
+        <p:nvPicPr>
+          <p:cNvPr id="150" name="Google Shape;150;p21" title="bodegas-lavaque-3-1.jpg"/>
+          <p:cNvPicPr preferRelativeResize="0"/>
+          <p:nvPr/>
+        </p:nvPicPr>
+        <p:blipFill>
+          <a:blip r:embed="rId4">
+            <a:alphaModFix/>
+          </a:blip>
+          <a:stretch>
+            <a:fillRect/>
+          </a:stretch>
+        </p:blipFill>
+        <p:spPr>
+          <a:xfrm>
+            <a:off x="6000750" y="1480100"/>
+            <a:ext cx="2881426" cy="2469200"/>
+          </a:xfrm>
+          <a:prstGeom prst="rect">
+            <a:avLst/>
+          </a:prstGeom>
+          <a:solidFill>
+            <a:srgbClr val="000000">
+              <a:alpha val="0"/>
+            </a:srgbClr>
+          </a:solidFill>
+          <a:ln cap="flat" cmpd="sng" w="14300">
+            <a:solidFill>
+              <a:srgbClr val="261418"/>
+            </a:solidFill>
+            <a:prstDash val="solid"/>
+            <a:round/>
+            <a:headEnd len="sm" w="sm" type="none"/>
+            <a:tailEnd len="sm" w="sm" type="none"/>
           </a:ln>
         </p:spPr>
       </p:pic>
@@ -10241,7 +11300,7 @@
                   <a:cs typeface="Nunito ExtraBold"/>
                   <a:sym typeface="Nunito ExtraBold"/>
                 </a:rPr>
-                <a:t>1. TRIGGER</a:t>
+                <a:t>1. ENTRY POINT</a:t>
               </a:r>
               <a:endParaRPr b="0" sz="620">
                 <a:solidFill>
@@ -10273,7 +11332,7 @@
                   <a:cs typeface="Nunito ExtraBold"/>
                   <a:sym typeface="Nunito ExtraBold"/>
                 </a:rPr>
-                <a:t>INV 2026</a:t>
+                <a:t>Export</a:t>
               </a:r>
               <a:endParaRPr b="0" sz="2170">
                 <a:solidFill>
@@ -10305,7 +11364,7 @@
                   <a:cs typeface="Nunito"/>
                   <a:sym typeface="Nunito"/>
                 </a:rPr>
-                <a:t>Regulation</a:t>
+                <a:t>Traceability</a:t>
               </a:r>
               <a:endParaRPr b="1" sz="1085">
                 <a:solidFill>
@@ -10337,7 +11396,7 @@
                   <a:cs typeface="Nunito"/>
                   <a:sym typeface="Nunito"/>
                 </a:rPr>
-                <a:t>Mandatory lot traceability for exports.</a:t>
+                <a:t>Wineries that export need lot traceability.</a:t>
               </a:r>
               <a:endParaRPr b="0" sz="775">
                 <a:solidFill>

</xml_diff>

<commit_message>
Afirmaciones que el programa respalda: renta bloqueada, registro on-chain y seis productos demo
La devolución v3 de Superteam marcó tres cosas sin respaldo:
- La renta por producto no es recuperable: el programa no tiene instrucción de cierre. README y arquitectura lo dicen.
- La diapositiva 3 hablaba de "digital tokens": cada unidad es una cuenta, un registro on-chain.
- La diapositiva 7 mostraba solo la comisión de red; ahora suma la renta por unidad.
Y docs/demo-qrs dice que son seis productos, cinco para el jurado y uno reservado.

Co-Authored-By: Claude Opus 5.5 <noreply@anthropic.com>
</commit_message>
<xml_diff>
--- a/PITCH/VeriFire Pitch Deck (EN).pptx
+++ b/PITCH/VeriFire Pitch Deck (EN).pptx
@@ -8762,7 +8762,7 @@
                 <a:cs typeface="Nunito"/>
                 <a:sym typeface="Nunito"/>
               </a:rPr>
-              <a:t>Link your physical goods to unforgeable digital tokens backed by the Solana network.</a:t>
+              <a:t>Link each physical unit to its own on-chain record, verified by the Solana network.</a:t>
             </a:r>
             <a:endParaRPr b="0" sz="1500">
               <a:solidFill>
@@ -10906,7 +10906,7 @@
                   <a:cs typeface="Nunito"/>
                   <a:sym typeface="Nunito"/>
                 </a:rPr>
-                <a:t>Minimal transaction cost</a:t>
+                <a:t>Plus ~0.005 SOL of account rent per unit, locked while it exists.</a:t>
               </a:r>
               <a:endParaRPr b="0" sz="1100">
                 <a:solidFill>

</xml_diff>